<commit_message>
Add source-backed P0-09 scenario production bundle
</commit_message>
<xml_diff>
--- a/docs/product/ppt-benchmark-materials/PPT-P0-09/p0-09-reference.pptx
+++ b/docs/product/ppt-benchmark-materials/PPT-P0-09/p0-09-reference.pptx
@@ -148,7 +148,7 @@
           </c:spPr>
           <c:invertIfNegative val="0"/>
           <c:dLbls>
-            <c:numFmt formatCode="#,##0" sourceLinked="0"/>
+            <c:numFmt formatCode="#,##0.########" sourceLinked="0"/>
             <c:txPr>
               <a:bodyPr/>
               <a:lstStyle/>
@@ -156,9 +156,9 @@
                 <a:pPr>
                   <a:defRPr b="0" i="0" strike="noStrike" sz="1200" u="none">
                     <a:solidFill>
-                      <a:srgbClr val="000000"/>
+                      <a:srgbClr val="183247"/>
                     </a:solidFill>
-                    <a:latin typeface="Arial"/>
+                    <a:latin typeface="Noto Sans CJK SC"/>
                   </a:defRPr>
                 </a:pPr>
               </a:p>
@@ -210,7 +210,7 @@
           </c:val>
         </c:ser>
         <c:dLbls>
-          <c:numFmt formatCode="#,##0" sourceLinked="0"/>
+          <c:numFmt formatCode="#,##0.########" sourceLinked="0"/>
           <c:txPr>
             <a:bodyPr/>
             <a:lstStyle/>
@@ -218,9 +218,9 @@
               <a:pPr>
                 <a:defRPr b="0" i="0" strike="noStrike" sz="1200" u="none">
                   <a:solidFill>
-                    <a:srgbClr val="000000"/>
+                    <a:srgbClr val="183247"/>
                   </a:solidFill>
-                  <a:latin typeface="Arial"/>
+                  <a:latin typeface="Noto Sans CJK SC"/>
                 </a:defRPr>
               </a:pPr>
             </a:p>
@@ -253,7 +253,7 @@
         <c:spPr>
           <a:ln w="12700" cap="flat">
             <a:solidFill>
-              <a:srgbClr val="888888"/>
+              <a:srgbClr val="183247"/>
             </a:solidFill>
             <a:prstDash val="solid"/>
             <a:round/>
@@ -266,7 +266,7 @@
             <a:pPr>
               <a:defRPr sz="1200" b="0" i="0" u="none" strike="noStrike">
                 <a:solidFill>
-                  <a:srgbClr val="000000"/>
+                  <a:srgbClr val="183247"/>
                 </a:solidFill>
                 <a:latin typeface="Noto Sans CJK SC"/>
               </a:defRPr>
@@ -292,7 +292,7 @@
           <c:spPr>
             <a:ln w="12700" cap="flat">
               <a:solidFill>
-                <a:srgbClr val="888888"/>
+                <a:srgbClr val="183247"/>
               </a:solidFill>
               <a:prstDash val="solid"/>
               <a:round/>
@@ -306,7 +306,7 @@
         <c:spPr>
           <a:ln w="12700" cap="flat">
             <a:solidFill>
-              <a:srgbClr val="888888"/>
+              <a:srgbClr val="183247"/>
             </a:solidFill>
             <a:prstDash val="solid"/>
             <a:round/>
@@ -319,7 +319,7 @@
             <a:pPr>
               <a:defRPr sz="1200" b="0" i="0" u="none" strike="noStrike">
                 <a:solidFill>
-                  <a:srgbClr val="000000"/>
+                  <a:srgbClr val="183247"/>
                 </a:solidFill>
                 <a:latin typeface="Noto Sans CJK SC"/>
               </a:defRPr>
@@ -332,7 +332,9 @@
         <c:crossBetween val="between"/>
       </c:valAx>
       <c:spPr>
-        <a:noFill/>
+        <a:solidFill>
+          <a:srgbClr val="FFFFFF"/>
+        </a:solidFill>
         <a:ln>
           <a:noFill/>
         </a:ln>
@@ -343,7 +345,9 @@
     <c:dispBlanksAs val="span"/>
   </c:chart>
   <c:spPr>
-    <a:noFill/>
+    <a:solidFill>
+      <a:srgbClr val="FFFFFF"/>
+    </a:solidFill>
     <a:ln>
       <a:noFill/>
     </a:ln>
@@ -389,7 +393,7 @@
           </c:spPr>
           <c:invertIfNegative val="0"/>
           <c:dLbls>
-            <c:numFmt formatCode="#,##0" sourceLinked="0"/>
+            <c:numFmt formatCode="#,##0.########" sourceLinked="0"/>
             <c:txPr>
               <a:bodyPr/>
               <a:lstStyle/>
@@ -397,9 +401,9 @@
                 <a:pPr>
                   <a:defRPr b="0" i="0" strike="noStrike" sz="1200" u="none">
                     <a:solidFill>
-                      <a:srgbClr val="000000"/>
+                      <a:srgbClr val="183247"/>
                     </a:solidFill>
-                    <a:latin typeface="Arial"/>
+                    <a:latin typeface="Noto Sans CJK SC"/>
                   </a:defRPr>
                 </a:pPr>
               </a:p>
@@ -451,7 +455,7 @@
           </c:val>
         </c:ser>
         <c:dLbls>
-          <c:numFmt formatCode="#,##0" sourceLinked="0"/>
+          <c:numFmt formatCode="#,##0.########" sourceLinked="0"/>
           <c:txPr>
             <a:bodyPr/>
             <a:lstStyle/>
@@ -459,9 +463,9 @@
               <a:pPr>
                 <a:defRPr b="0" i="0" strike="noStrike" sz="1200" u="none">
                   <a:solidFill>
-                    <a:srgbClr val="000000"/>
+                    <a:srgbClr val="183247"/>
                   </a:solidFill>
-                  <a:latin typeface="Arial"/>
+                  <a:latin typeface="Noto Sans CJK SC"/>
                 </a:defRPr>
               </a:pPr>
             </a:p>
@@ -494,7 +498,7 @@
         <c:spPr>
           <a:ln w="12700" cap="flat">
             <a:solidFill>
-              <a:srgbClr val="888888"/>
+              <a:srgbClr val="183247"/>
             </a:solidFill>
             <a:prstDash val="solid"/>
             <a:round/>
@@ -507,7 +511,7 @@
             <a:pPr>
               <a:defRPr sz="1200" b="0" i="0" u="none" strike="noStrike">
                 <a:solidFill>
-                  <a:srgbClr val="000000"/>
+                  <a:srgbClr val="183247"/>
                 </a:solidFill>
                 <a:latin typeface="Noto Sans CJK SC"/>
               </a:defRPr>
@@ -533,7 +537,7 @@
           <c:spPr>
             <a:ln w="12700" cap="flat">
               <a:solidFill>
-                <a:srgbClr val="888888"/>
+                <a:srgbClr val="183247"/>
               </a:solidFill>
               <a:prstDash val="solid"/>
               <a:round/>
@@ -547,7 +551,7 @@
         <c:spPr>
           <a:ln w="12700" cap="flat">
             <a:solidFill>
-              <a:srgbClr val="888888"/>
+              <a:srgbClr val="183247"/>
             </a:solidFill>
             <a:prstDash val="solid"/>
             <a:round/>
@@ -560,7 +564,7 @@
             <a:pPr>
               <a:defRPr sz="1200" b="0" i="0" u="none" strike="noStrike">
                 <a:solidFill>
-                  <a:srgbClr val="000000"/>
+                  <a:srgbClr val="183247"/>
                 </a:solidFill>
                 <a:latin typeface="Noto Sans CJK SC"/>
               </a:defRPr>
@@ -573,7 +577,9 @@
         <c:crossBetween val="between"/>
       </c:valAx>
       <c:spPr>
-        <a:noFill/>
+        <a:solidFill>
+          <a:srgbClr val="FFFFFF"/>
+        </a:solidFill>
         <a:ln>
           <a:noFill/>
         </a:ln>
@@ -584,7 +590,9 @@
     <c:dispBlanksAs val="span"/>
   </c:chart>
   <c:spPr>
-    <a:noFill/>
+    <a:solidFill>
+      <a:srgbClr val="FFFFFF"/>
+    </a:solidFill>
     <a:ln>
       <a:noFill/>
     </a:ln>
@@ -993,6 +1001,8 @@
               <a:rPr lang="en-US" dirty="0"/>
               <a:t>封面：历史披露与假设边界
 参考稿：历史披露与自制假设分开；非 Apple 指引或预测。
+[model-boundary] local:model-inputs.json · model.scenarios / model.formulas
+三种情景由 WisWork 自制，仅是假设性演示，非 Apple 指引或预测。
 Attribution supplied by the input; source accuracy and license rights have not been independently verified.</a:t>
             </a:r>
             <a:endParaRPr lang="en-US" dirty="0"/>
@@ -1083,6 +1093,10 @@
               <a:rPr lang="en-US" dirty="0"/>
               <a:t>目录与口径
 参考稿：历史披露与自制假设分开；非 Apple 指引或预测。
+[historical] https://www.apple.com/newsroom/pdfs/fy2024-q4/FY24_Q4_Consolidated_Financial_Statements.pdf ; https://www.apple.com/newsroom/pdfs/fy2024-q4/FY24_Q4_Consolidated_Financial_Statements.pdf · PDF 1 FY2024 12 months ; PDF 1 FY2024 12 months
+Apple FY2024 截至 2024-09-28 的十二个月，净销售额 391,035、营业利润 123,216 百万美元，官方表格未经审计。
+[model-boundary] local:model-inputs.json · model.scenarios / model.formulas
+三种情景由 WisWork 自制，仅是假设性演示，非 Apple 指引或预测。
 Attribution supplied by the input; source accuracy and license rights have not been independently verified.</a:t>
             </a:r>
             <a:endParaRPr lang="en-US" dirty="0"/>
@@ -1173,8 +1187,8 @@
               <a:rPr lang="en-US" dirty="0"/>
               <a:t>2024 财年历史披露
 参考稿：历史披露与自制假设分开；非 Apple 指引或预测。
-[historical-2024] Apple Inc. 2024-10-31 Consolidated Financial Statements (Unaudited) · 第 1 页；截至 2024-09-28 的十二个月
-2024 财年净销售额 391,035、营业利润 123,216，单位百万美元
+[historical] https://www.apple.com/newsroom/pdfs/fy2024-q4/FY24_Q4_Consolidated_Financial_Statements.pdf ; https://www.apple.com/newsroom/pdfs/fy2024-q4/FY24_Q4_Consolidated_Financial_Statements.pdf · PDF 1 FY2024 12 months ; PDF 1 FY2024 12 months
+Apple FY2024 截至 2024-09-28 的十二个月，净销售额 391,035、营业利润 123,216 百万美元，官方表格未经审计。
 Attribution supplied by the input; source accuracy and license rights have not been independently verified.</a:t>
             </a:r>
             <a:endParaRPr lang="en-US" dirty="0"/>
@@ -1265,6 +1279,8 @@
               <a:rPr lang="en-US" dirty="0"/>
               <a:t>情景输入与公式
 参考稿：历史披露与自制假设分开；非 Apple 指引或预测。
+[model-boundary] local:model-inputs.json · model.scenarios / model.formulas
+三种情景由 WisWork 自制，仅是假设性演示，非 Apple 指引或预测。
 Attribution supplied by the input; source accuracy and license rights have not been independently verified.</a:t>
             </a:r>
             <a:endParaRPr lang="en-US" dirty="0"/>
@@ -1355,6 +1371,12 @@
               <a:rPr lang="en-US" dirty="0"/>
               <a:t>三情景收入原生图表（百万美元）
 参考稿：历史披露与自制假设分开；非 Apple 指引或预测。
+[downside-sales] local:model-inputs.json ; local:scenario-results.csv · model.scenarios / model.formulas ; CSV downside
+下行假设净销售额 371,483 百万美元，仅为自制假设结果。
+[base-sales] local:model-inputs.json ; local:scenario-results.csv · model.scenarios / model.formulas ; CSV base
+基准假设净销售额 402,766 百万美元，仅为自制假设结果。
+[upside-sales] local:model-inputs.json ; local:scenario-results.csv · model.scenarios / model.formulas ; CSV upside
+上行假设净销售额 422,318 百万美元，仅为自制假设结果。
 Attribution supplied by the input; source accuracy and license rights have not been independently verified.</a:t>
             </a:r>
             <a:endParaRPr lang="en-US" dirty="0"/>
@@ -1445,6 +1467,12 @@
               <a:rPr lang="en-US" dirty="0"/>
               <a:t>三情景营业利润原生图表（百万美元）
 参考稿：历史披露与自制假设分开；非 Apple 指引或预测。
+[downside-income] local:model-inputs.json ; local:scenario-results.csv · model.scenarios / model.formulas ; CSV downside
+下行假设营业利润 109,587 百万美元，仅为自制假设结果。
+[base-income] local:model-inputs.json ; local:scenario-results.csv · model.scenarios / model.formulas ; CSV base
+基准假设营业利润 126,871 百万美元，仅为自制假设结果。
+[upside-income] local:model-inputs.json ; local:scenario-results.csv · model.scenarios / model.formulas ; CSV upside
+上行假设营业利润 141,477 百万美元，仅为自制假设结果。
 Attribution supplied by the input; source accuracy and license rights have not been independently verified.</a:t>
             </a:r>
             <a:endParaRPr lang="en-US" dirty="0"/>
@@ -1535,6 +1563,8 @@
               <a:rPr lang="en-US" dirty="0"/>
               <a:t>敏感参数与不可推断事项
 参考稿：历史披露与自制假设分开；非 Apple 指引或预测。
+[model-boundary] local:model-inputs.json · model.scenarios / model.formulas
+三种情景由 WisWork 自制，仅是假设性演示，非 Apple 指引或预测。
 Attribution supplied by the input; source accuracy and license rights have not been independently verified.</a:t>
             </a:r>
             <a:endParaRPr lang="en-US" dirty="0"/>
@@ -1625,6 +1655,10 @@
               <a:rPr lang="en-US" dirty="0"/>
               <a:t>结论、局限与人工审阅
 参考稿：历史披露与自制假设分开；非 Apple 指引或预测。
+[historical] https://www.apple.com/newsroom/pdfs/fy2024-q4/FY24_Q4_Consolidated_Financial_Statements.pdf ; https://www.apple.com/newsroom/pdfs/fy2024-q4/FY24_Q4_Consolidated_Financial_Statements.pdf · PDF 1 FY2024 12 months ; PDF 1 FY2024 12 months
+Apple FY2024 截至 2024-09-28 的十二个月，净销售额 391,035、营业利润 123,216 百万美元，官方表格未经审计。
+[model-boundary] local:model-inputs.json · model.scenarios / model.formulas
+三种情景由 WisWork 自制，仅是假设性演示，非 Apple 指引或预测。
 Attribution supplied by the input; source accuracy and license rights have not been independently verified.</a:t>
             </a:r>
             <a:endParaRPr lang="en-US" dirty="0"/>
@@ -2084,7 +2118,7 @@
         </p:nvSpPr>
         <p:spPr>
           <a:xfrm>
-            <a:off x="822960" y="6355080"/>
+            <a:off x="822960" y="6053328"/>
             <a:ext cx="10424160" cy="228600"/>
           </a:xfrm>
           <a:prstGeom prst="rect">
@@ -2112,6 +2146,45 @@
               <a:t>情景假设：WisWork 自制，仅供基准测试；非 Apple 指引</a:t>
             </a:r>
             <a:endParaRPr lang="en-US" sz="900" dirty="0"/>
+          </a:p>
+        </p:txBody>
+      </p:sp>
+      <p:sp>
+        <p:nvSpPr>
+          <p:cNvPr id="5" name="source-attribution"/>
+          <p:cNvSpPr/>
+          <p:nvPr/>
+        </p:nvSpPr>
+        <p:spPr>
+          <a:xfrm>
+            <a:off x="457200" y="6446520"/>
+            <a:ext cx="11247120" cy="274320"/>
+          </a:xfrm>
+          <a:prstGeom prst="rect">
+            <a:avLst/>
+          </a:prstGeom>
+          <a:noFill/>
+          <a:ln/>
+        </p:spPr>
+        <p:txBody>
+          <a:bodyPr wrap="square" lIns="0" tIns="0" rIns="0" bIns="0" rtlCol="0" anchor="t"/>
+          <a:lstStyle/>
+          <a:p>
+            <a:pPr algn="l" indent="0" marL="0">
+              <a:buNone/>
+            </a:pPr>
+            <a:r>
+              <a:rPr lang="en-US" sz="800" dirty="0">
+                <a:solidFill>
+                  <a:srgbClr val="183247"/>
+                </a:solidFill>
+                <a:latin typeface="Noto Sans CJK SC" pitchFamily="34" charset="0"/>
+                <a:ea typeface="Noto Sans CJK SC" pitchFamily="34" charset="-122"/>
+                <a:cs typeface="Noto Sans CJK SC" pitchFamily="34" charset="-120"/>
+              </a:rPr>
+              <a:t>[model-boundary] local:model-inputs.json · model.scenarios / model.formulas</a:t>
+            </a:r>
+            <a:endParaRPr lang="en-US" sz="800" dirty="0"/>
           </a:p>
         </p:txBody>
       </p:sp>
@@ -2233,7 +2306,7 @@
         </p:nvSpPr>
         <p:spPr>
           <a:xfrm>
-            <a:off x="822960" y="6355080"/>
+            <a:off x="822960" y="6053328"/>
             <a:ext cx="10424160" cy="228600"/>
           </a:xfrm>
           <a:prstGeom prst="rect">
@@ -2261,6 +2334,45 @@
               <a:t>情景假设：WisWork 自制，仅供基准测试；非 Apple 指引</a:t>
             </a:r>
             <a:endParaRPr lang="en-US" sz="900" dirty="0"/>
+          </a:p>
+        </p:txBody>
+      </p:sp>
+      <p:sp>
+        <p:nvSpPr>
+          <p:cNvPr id="5" name="source-attribution"/>
+          <p:cNvSpPr/>
+          <p:nvPr/>
+        </p:nvSpPr>
+        <p:spPr>
+          <a:xfrm>
+            <a:off x="457200" y="6446520"/>
+            <a:ext cx="11247120" cy="274320"/>
+          </a:xfrm>
+          <a:prstGeom prst="rect">
+            <a:avLst/>
+          </a:prstGeom>
+          <a:noFill/>
+          <a:ln/>
+        </p:spPr>
+        <p:txBody>
+          <a:bodyPr wrap="square" lIns="0" tIns="0" rIns="0" bIns="0" rtlCol="0" anchor="t"/>
+          <a:lstStyle/>
+          <a:p>
+            <a:pPr algn="l" indent="0" marL="0">
+              <a:buNone/>
+            </a:pPr>
+            <a:r>
+              <a:rPr lang="en-US" sz="800" dirty="0">
+                <a:solidFill>
+                  <a:srgbClr val="183247"/>
+                </a:solidFill>
+                <a:latin typeface="Noto Sans CJK SC" pitchFamily="34" charset="0"/>
+                <a:ea typeface="Noto Sans CJK SC" pitchFamily="34" charset="-122"/>
+                <a:cs typeface="Noto Sans CJK SC" pitchFamily="34" charset="-120"/>
+              </a:rPr>
+              <a:t>[historical] https://www.apple.com/newsroom/pdfs/fy2024-q4/FY24_Q4_Consolidated_Financial_Statements.pdf ; https://www.apple.com/newsroom/pdfs/fy2024-q4/FY24_Q4_Consolidated_Financial_Statements.pdf · PDF 1 FY2024 12 months ; PDF 1 FY2024 12 months；[model-boundary] local:model-inputs.json · model.scenarios / model.formulas</a:t>
+            </a:r>
+            <a:endParaRPr lang="en-US" sz="800" dirty="0"/>
           </a:p>
         </p:txBody>
       </p:sp>
@@ -2382,7 +2494,7 @@
         </p:nvSpPr>
         <p:spPr>
           <a:xfrm>
-            <a:off x="822960" y="6355080"/>
+            <a:off x="822960" y="6053328"/>
             <a:ext cx="10424160" cy="228600"/>
           </a:xfrm>
           <a:prstGeom prst="rect">
@@ -2431,10 +2543,10 @@
           <a:ln/>
         </p:spPr>
         <p:txBody>
-          <a:bodyPr wrap="square" lIns="0" tIns="0" rIns="0" bIns="0" rtlCol="0" anchor="ctr"/>
-          <a:lstStyle/>
-          <a:p>
-            <a:pPr indent="0" marL="0">
+          <a:bodyPr wrap="square" lIns="0" tIns="0" rIns="0" bIns="0" rtlCol="0" anchor="t"/>
+          <a:lstStyle/>
+          <a:p>
+            <a:pPr algn="l" indent="0" marL="0">
               <a:buNone/>
             </a:pPr>
             <a:r>
@@ -2446,7 +2558,7 @@
                 <a:ea typeface="Noto Sans CJK SC" pitchFamily="34" charset="-122"/>
                 <a:cs typeface="Noto Sans CJK SC" pitchFamily="34" charset="-120"/>
               </a:rPr>
-              <a:t>[historical-2024] Apple Inc. 2024-10-31 Consolidated Financial Statements (Unaudited) · 第 1 页；截至 2024-09-28 的十二个月</a:t>
+              <a:t>[historical] https://www.apple.com/newsroom/pdfs/fy2024-q4/FY24_Q4_Consolidated_Financial_Statements.pdf ; https://www.apple.com/newsroom/pdfs/fy2024-q4/FY24_Q4_Consolidated_Financial_Statements.pdf · PDF 1 FY2024 12 months ; PDF 1 FY2024 12 months</a:t>
             </a:r>
             <a:endParaRPr lang="en-US" sz="800" dirty="0"/>
           </a:p>
@@ -2570,7 +2682,7 @@
         </p:nvSpPr>
         <p:spPr>
           <a:xfrm>
-            <a:off x="822960" y="6355080"/>
+            <a:off x="822960" y="6053328"/>
             <a:ext cx="10424160" cy="228600"/>
           </a:xfrm>
           <a:prstGeom prst="rect">
@@ -2598,6 +2710,45 @@
               <a:t>情景假设：WisWork 自制，仅供基准测试；非 Apple 指引</a:t>
             </a:r>
             <a:endParaRPr lang="en-US" sz="900" dirty="0"/>
+          </a:p>
+        </p:txBody>
+      </p:sp>
+      <p:sp>
+        <p:nvSpPr>
+          <p:cNvPr id="5" name="source-attribution"/>
+          <p:cNvSpPr/>
+          <p:nvPr/>
+        </p:nvSpPr>
+        <p:spPr>
+          <a:xfrm>
+            <a:off x="457200" y="6446520"/>
+            <a:ext cx="11247120" cy="274320"/>
+          </a:xfrm>
+          <a:prstGeom prst="rect">
+            <a:avLst/>
+          </a:prstGeom>
+          <a:noFill/>
+          <a:ln/>
+        </p:spPr>
+        <p:txBody>
+          <a:bodyPr wrap="square" lIns="0" tIns="0" rIns="0" bIns="0" rtlCol="0" anchor="t"/>
+          <a:lstStyle/>
+          <a:p>
+            <a:pPr algn="l" indent="0" marL="0">
+              <a:buNone/>
+            </a:pPr>
+            <a:r>
+              <a:rPr lang="en-US" sz="800" dirty="0">
+                <a:solidFill>
+                  <a:srgbClr val="183247"/>
+                </a:solidFill>
+                <a:latin typeface="Noto Sans CJK SC" pitchFamily="34" charset="0"/>
+                <a:ea typeface="Noto Sans CJK SC" pitchFamily="34" charset="-122"/>
+                <a:cs typeface="Noto Sans CJK SC" pitchFamily="34" charset="-120"/>
+              </a:rPr>
+              <a:t>[model-boundary] local:model-inputs.json · model.scenarios / model.formulas</a:t>
+            </a:r>
+            <a:endParaRPr lang="en-US" sz="800" dirty="0"/>
           </a:p>
         </p:txBody>
       </p:sp>
@@ -2735,7 +2886,7 @@
         </p:nvSpPr>
         <p:spPr>
           <a:xfrm>
-            <a:off x="822960" y="6355080"/>
+            <a:off x="822960" y="6053328"/>
             <a:ext cx="10424160" cy="228600"/>
           </a:xfrm>
           <a:prstGeom prst="rect">
@@ -2763,6 +2914,45 @@
               <a:t>情景假设：WisWork 自制，仅供基准测试；非 Apple 指引</a:t>
             </a:r>
             <a:endParaRPr lang="en-US" sz="900" dirty="0"/>
+          </a:p>
+        </p:txBody>
+      </p:sp>
+      <p:sp>
+        <p:nvSpPr>
+          <p:cNvPr id="6" name="source-attribution"/>
+          <p:cNvSpPr/>
+          <p:nvPr/>
+        </p:nvSpPr>
+        <p:spPr>
+          <a:xfrm>
+            <a:off x="457200" y="6446520"/>
+            <a:ext cx="11247120" cy="274320"/>
+          </a:xfrm>
+          <a:prstGeom prst="rect">
+            <a:avLst/>
+          </a:prstGeom>
+          <a:noFill/>
+          <a:ln/>
+        </p:spPr>
+        <p:txBody>
+          <a:bodyPr wrap="square" lIns="0" tIns="0" rIns="0" bIns="0" rtlCol="0" anchor="t"/>
+          <a:lstStyle/>
+          <a:p>
+            <a:pPr algn="l" indent="0" marL="0">
+              <a:buNone/>
+            </a:pPr>
+            <a:r>
+              <a:rPr lang="en-US" sz="800" dirty="0">
+                <a:solidFill>
+                  <a:srgbClr val="183247"/>
+                </a:solidFill>
+                <a:latin typeface="Noto Sans CJK SC" pitchFamily="34" charset="0"/>
+                <a:ea typeface="Noto Sans CJK SC" pitchFamily="34" charset="-122"/>
+                <a:cs typeface="Noto Sans CJK SC" pitchFamily="34" charset="-120"/>
+              </a:rPr>
+              <a:t>[downside-sales] local:model-inputs.json ; local:scenario-results.csv · model.scenarios / model.formulas ; CSV downside；[base-sales] local:model-inputs.json ; local:scenario-results.csv · model.scenarios / model.formulas ; CSV base；[upside-sales] local:model-inputs.json ; local:scenario-results.csv · model.scenarios / model.formulas ; CSV upside</a:t>
+            </a:r>
+            <a:endParaRPr lang="en-US" sz="800" dirty="0"/>
           </a:p>
         </p:txBody>
       </p:sp>
@@ -2900,7 +3090,7 @@
         </p:nvSpPr>
         <p:spPr>
           <a:xfrm>
-            <a:off x="822960" y="6355080"/>
+            <a:off x="822960" y="6053328"/>
             <a:ext cx="10424160" cy="228600"/>
           </a:xfrm>
           <a:prstGeom prst="rect">
@@ -2928,6 +3118,45 @@
               <a:t>情景假设：WisWork 自制，仅供基准测试；非 Apple 指引</a:t>
             </a:r>
             <a:endParaRPr lang="en-US" sz="900" dirty="0"/>
+          </a:p>
+        </p:txBody>
+      </p:sp>
+      <p:sp>
+        <p:nvSpPr>
+          <p:cNvPr id="6" name="source-attribution"/>
+          <p:cNvSpPr/>
+          <p:nvPr/>
+        </p:nvSpPr>
+        <p:spPr>
+          <a:xfrm>
+            <a:off x="457200" y="6446520"/>
+            <a:ext cx="11247120" cy="274320"/>
+          </a:xfrm>
+          <a:prstGeom prst="rect">
+            <a:avLst/>
+          </a:prstGeom>
+          <a:noFill/>
+          <a:ln/>
+        </p:spPr>
+        <p:txBody>
+          <a:bodyPr wrap="square" lIns="0" tIns="0" rIns="0" bIns="0" rtlCol="0" anchor="t"/>
+          <a:lstStyle/>
+          <a:p>
+            <a:pPr algn="l" indent="0" marL="0">
+              <a:buNone/>
+            </a:pPr>
+            <a:r>
+              <a:rPr lang="en-US" sz="800" dirty="0">
+                <a:solidFill>
+                  <a:srgbClr val="183247"/>
+                </a:solidFill>
+                <a:latin typeface="Noto Sans CJK SC" pitchFamily="34" charset="0"/>
+                <a:ea typeface="Noto Sans CJK SC" pitchFamily="34" charset="-122"/>
+                <a:cs typeface="Noto Sans CJK SC" pitchFamily="34" charset="-120"/>
+              </a:rPr>
+              <a:t>[downside-income] local:model-inputs.json ; local:scenario-results.csv · model.scenarios / model.formulas ; CSV downside；[base-income] local:model-inputs.json ; local:scenario-results.csv · model.scenarios / model.formulas ; CSV base；[upside-income] local:model-inputs.json ; local:scenario-results.csv · model.scenarios / model.formulas ; CSV upside</a:t>
+            </a:r>
+            <a:endParaRPr lang="en-US" sz="800" dirty="0"/>
           </a:p>
         </p:txBody>
       </p:sp>
@@ -3049,7 +3278,7 @@
         </p:nvSpPr>
         <p:spPr>
           <a:xfrm>
-            <a:off x="822960" y="6355080"/>
+            <a:off x="822960" y="6053328"/>
             <a:ext cx="10424160" cy="228600"/>
           </a:xfrm>
           <a:prstGeom prst="rect">
@@ -3077,6 +3306,45 @@
               <a:t>情景假设：WisWork 自制，仅供基准测试；非 Apple 指引</a:t>
             </a:r>
             <a:endParaRPr lang="en-US" sz="900" dirty="0"/>
+          </a:p>
+        </p:txBody>
+      </p:sp>
+      <p:sp>
+        <p:nvSpPr>
+          <p:cNvPr id="5" name="source-attribution"/>
+          <p:cNvSpPr/>
+          <p:nvPr/>
+        </p:nvSpPr>
+        <p:spPr>
+          <a:xfrm>
+            <a:off x="457200" y="6446520"/>
+            <a:ext cx="11247120" cy="274320"/>
+          </a:xfrm>
+          <a:prstGeom prst="rect">
+            <a:avLst/>
+          </a:prstGeom>
+          <a:noFill/>
+          <a:ln/>
+        </p:spPr>
+        <p:txBody>
+          <a:bodyPr wrap="square" lIns="0" tIns="0" rIns="0" bIns="0" rtlCol="0" anchor="t"/>
+          <a:lstStyle/>
+          <a:p>
+            <a:pPr algn="l" indent="0" marL="0">
+              <a:buNone/>
+            </a:pPr>
+            <a:r>
+              <a:rPr lang="en-US" sz="800" dirty="0">
+                <a:solidFill>
+                  <a:srgbClr val="183247"/>
+                </a:solidFill>
+                <a:latin typeface="Noto Sans CJK SC" pitchFamily="34" charset="0"/>
+                <a:ea typeface="Noto Sans CJK SC" pitchFamily="34" charset="-122"/>
+                <a:cs typeface="Noto Sans CJK SC" pitchFamily="34" charset="-120"/>
+              </a:rPr>
+              <a:t>[model-boundary] local:model-inputs.json · model.scenarios / model.formulas</a:t>
+            </a:r>
+            <a:endParaRPr lang="en-US" sz="800" dirty="0"/>
           </a:p>
         </p:txBody>
       </p:sp>
@@ -3198,7 +3466,7 @@
         </p:nvSpPr>
         <p:spPr>
           <a:xfrm>
-            <a:off x="822960" y="6355080"/>
+            <a:off x="822960" y="6053328"/>
             <a:ext cx="10424160" cy="228600"/>
           </a:xfrm>
           <a:prstGeom prst="rect">
@@ -3226,6 +3494,45 @@
               <a:t>情景假设：WisWork 自制，仅供基准测试；非 Apple 指引</a:t>
             </a:r>
             <a:endParaRPr lang="en-US" sz="900" dirty="0"/>
+          </a:p>
+        </p:txBody>
+      </p:sp>
+      <p:sp>
+        <p:nvSpPr>
+          <p:cNvPr id="5" name="source-attribution"/>
+          <p:cNvSpPr/>
+          <p:nvPr/>
+        </p:nvSpPr>
+        <p:spPr>
+          <a:xfrm>
+            <a:off x="457200" y="6446520"/>
+            <a:ext cx="11247120" cy="274320"/>
+          </a:xfrm>
+          <a:prstGeom prst="rect">
+            <a:avLst/>
+          </a:prstGeom>
+          <a:noFill/>
+          <a:ln/>
+        </p:spPr>
+        <p:txBody>
+          <a:bodyPr wrap="square" lIns="0" tIns="0" rIns="0" bIns="0" rtlCol="0" anchor="t"/>
+          <a:lstStyle/>
+          <a:p>
+            <a:pPr algn="l" indent="0" marL="0">
+              <a:buNone/>
+            </a:pPr>
+            <a:r>
+              <a:rPr lang="en-US" sz="800" dirty="0">
+                <a:solidFill>
+                  <a:srgbClr val="183247"/>
+                </a:solidFill>
+                <a:latin typeface="Noto Sans CJK SC" pitchFamily="34" charset="0"/>
+                <a:ea typeface="Noto Sans CJK SC" pitchFamily="34" charset="-122"/>
+                <a:cs typeface="Noto Sans CJK SC" pitchFamily="34" charset="-120"/>
+              </a:rPr>
+              <a:t>[historical] https://www.apple.com/newsroom/pdfs/fy2024-q4/FY24_Q4_Consolidated_Financial_Statements.pdf ; https://www.apple.com/newsroom/pdfs/fy2024-q4/FY24_Q4_Consolidated_Financial_Statements.pdf · PDF 1 FY2024 12 months ; PDF 1 FY2024 12 months；[model-boundary] local:model-inputs.json · model.scenarios / model.formulas</a:t>
+            </a:r>
+            <a:endParaRPr lang="en-US" sz="800" dirty="0"/>
           </a:p>
         </p:txBody>
       </p:sp>

</xml_diff>